<commit_message>
public: arquivos estaticos servidos na raiz (imagens, audio, slides e pdf)
</commit_message>
<xml_diff>
--- a/public/Relatorio_Atividade_2_Slides.pptx
+++ b/public/Relatorio_Atividade_2_Slides.pptx
@@ -5099,6 +5099,20 @@
               </a:defRPr>
             </a:pPr>
             <a:r>
+              <a:t>• LENNON, John. Imagine. In: Imagine. Produção: John Lennon, Yoko Ono, Phil Spector. Ascot Sound Studios: Apple Records, 1971. 1 faixa musical (3 min 3 s). Uso pedagógico e cultural.</a:t>
+            </a:r>
+          </a:p>
+          <a:p>
+            <a:br/>
+            <a:pPr>
+              <a:defRPr sz="950">
+                <a:solidFill>
+                  <a:srgbClr val="64748B"/>
+                </a:solidFill>
+                <a:latin typeface="Arial"/>
+              </a:defRPr>
+            </a:pPr>
+            <a:r>
               <a:t>• MDN WEB DOCS. Fetch API. Mozilla Developer Network, 2026. Disponível em: &lt;https://developer.mozilla.org/pt-BR/docs/Web/API/Fetch_API&gt;. Acesso em: 17 set. 2026.</a:t>
             </a:r>
           </a:p>
@@ -6558,7 +6572,7 @@
               </a:defRPr>
             </a:pPr>
             <a:r>
-              <a:t>A Música que Conecta Gerações</a:t>
+              <a:t>A Música que Conecta Gerações (Imagine — John Lennon, 1971)</a:t>
             </a:r>
           </a:p>
           <a:p>
@@ -6572,7 +6586,7 @@
               </a:defRPr>
             </a:pPr>
             <a:r>
-              <a:t>Nenhum projeto comunitário vive só de botões; ele vive de sentimento. O componente PlayerAudio.jsx traz a música 'Imagine' como pano de fundo de esperança.</a:t>
+              <a:t>Nenhum projeto comunitário vive só de botões; ele vive de sentimento. O componente PlayerAudio.jsx traz a clássica canção 'Imagine' de John Lennon (1971) como trilha sonora de paz e união, executada para fins pedagógicos e culturais.</a:t>
             </a:r>
           </a:p>
           <a:p>

</xml_diff>

<commit_message>
Relatorio_Atividade_2_Slides.pptx: apresentacao editavel em powerpoint com cabecalho institucional completo
</commit_message>
<xml_diff>
--- a/public/Relatorio_Atividade_2_Slides.pptx
+++ b/public/Relatorio_Atividade_2_Slides.pptx
@@ -3145,20 +3145,164 @@
       </p:sp>
       <p:sp>
         <p:nvSpPr>
-          <p:cNvPr id="3" name="Rounded Rectangle 2"/>
+          <p:cNvPr id="3" name="TextBox 2"/>
+          <p:cNvSpPr txBox="1"/>
+          <p:nvPr/>
+        </p:nvSpPr>
+        <p:spPr>
+          <a:xfrm>
+            <a:off x="822960" y="274320"/>
+            <a:ext cx="6858000" cy="1508760"/>
+          </a:xfrm>
+          <a:prstGeom prst="rect">
+            <a:avLst/>
+          </a:prstGeom>
+          <a:noFill/>
+        </p:spPr>
+        <p:txBody>
+          <a:bodyPr wrap="square" lIns="0" tIns="0" rIns="0" bIns="0">
+            <a:spAutoFit/>
+          </a:bodyPr>
+          <a:lstStyle/>
+          <a:p>
+            <a:pPr>
+              <a:defRPr sz="1150" b="1">
+                <a:solidFill>
+                  <a:srgbClr val="FFFFFF"/>
+                </a:solidFill>
+                <a:latin typeface="Segoe UI"/>
+              </a:defRPr>
+            </a:pPr>
+            <a:r>
+              <a:t>UNIVERSIDADE ESTADUAL DO MARANHÃO – UEMA</a:t>
+            </a:r>
+          </a:p>
+          <a:p>
+            <a:pPr>
+              <a:defRPr sz="1050" b="1">
+                <a:solidFill>
+                  <a:srgbClr val="4ADE80"/>
+                </a:solidFill>
+                <a:latin typeface="Segoe UI"/>
+              </a:defRPr>
+            </a:pPr>
+            <a:r>
+              <a:t>NÚCLEO DE TECNOLOGIAS PARA EDUCAÇÃO – UEMANET</a:t>
+            </a:r>
+          </a:p>
+          <a:p>
+            <a:pPr>
+              <a:defRPr sz="950" b="1">
+                <a:solidFill>
+                  <a:srgbClr val="E2E8F0"/>
+                </a:solidFill>
+                <a:latin typeface="Segoe UI"/>
+              </a:defRPr>
+            </a:pPr>
+            <a:r>
+              <a:t>CURSO SUPERIOR DE TECNOLOGIA EM ANÁLISE E DESENVOLVIMENTO DE SISTEMAS</a:t>
+            </a:r>
+          </a:p>
+          <a:p>
+            <a:pPr>
+              <a:defRPr sz="900" b="1">
+                <a:solidFill>
+                  <a:srgbClr val="CBD5E1"/>
+                </a:solidFill>
+                <a:latin typeface="Segoe UI"/>
+              </a:defRPr>
+            </a:pPr>
+            <a:r>
+              <a:t>DISCIPLINA: DESENVOLVIMENTO WEB</a:t>
+            </a:r>
+          </a:p>
+          <a:p>
+            <a:pPr>
+              <a:defRPr sz="900" b="1">
+                <a:solidFill>
+                  <a:srgbClr val="CBD5E1"/>
+                </a:solidFill>
+                <a:latin typeface="Segoe UI"/>
+              </a:defRPr>
+            </a:pPr>
+            <a:r>
+              <a:t>DOCENTE: PROF. EDILSON CARLOS SILVA LIMA</a:t>
+            </a:r>
+          </a:p>
+          <a:p>
+            <a:pPr>
+              <a:defRPr sz="900" b="1">
+                <a:solidFill>
+                  <a:srgbClr val="CBD5E1"/>
+                </a:solidFill>
+                <a:latin typeface="Segoe UI"/>
+              </a:defRPr>
+            </a:pPr>
+            <a:r>
+              <a:t>TUTORA: PROF.ª SIMONE</a:t>
+            </a:r>
+          </a:p>
+        </p:txBody>
+      </p:sp>
+      <p:sp>
+        <p:nvSpPr>
+          <p:cNvPr id="4" name="Rectangle 3"/>
           <p:cNvSpPr/>
           <p:nvPr/>
         </p:nvSpPr>
         <p:spPr>
           <a:xfrm>
-            <a:off x="2011680" y="685800"/>
-            <a:ext cx="8168335" cy="438912"/>
+            <a:off x="822960" y="1783080"/>
+            <a:ext cx="10545775" cy="13716"/>
+          </a:xfrm>
+          <a:prstGeom prst="rect">
+            <a:avLst/>
+          </a:prstGeom>
+          <a:solidFill>
+            <a:srgbClr val="166534"/>
+          </a:solidFill>
+          <a:ln>
+            <a:noFill/>
+          </a:ln>
+        </p:spPr>
+        <p:style>
+          <a:lnRef idx="1">
+            <a:schemeClr val="accent1"/>
+          </a:lnRef>
+          <a:fillRef idx="3">
+            <a:schemeClr val="accent1"/>
+          </a:fillRef>
+          <a:effectRef idx="2">
+            <a:schemeClr val="accent1"/>
+          </a:effectRef>
+          <a:fontRef idx="minor">
+            <a:schemeClr val="lt1"/>
+          </a:fontRef>
+        </p:style>
+        <p:txBody>
+          <a:bodyPr rtlCol="0" anchor="ctr"/>
+          <a:lstStyle/>
+          <a:p>
+            <a:pPr algn="ctr"/>
+          </a:p>
+        </p:txBody>
+      </p:sp>
+      <p:sp>
+        <p:nvSpPr>
+          <p:cNvPr id="5" name="Rounded Rectangle 4"/>
+          <p:cNvSpPr/>
+          <p:nvPr/>
+        </p:nvSpPr>
+        <p:spPr>
+          <a:xfrm>
+            <a:off x="2926080" y="1965960"/>
+            <a:ext cx="6339535" cy="365760"/>
           </a:xfrm>
           <a:prstGeom prst="roundRect">
             <a:avLst/>
           </a:prstGeom>
           <a:solidFill>
-            <a:srgbClr val="0F3D24"/>
+            <a:srgbClr val="0C321D"/>
           </a:solidFill>
           <a:ln w="15240">
             <a:solidFill>
@@ -3181,83 +3325,11 @@
           </a:fontRef>
         </p:style>
         <p:txBody>
-          <a:bodyPr rtlCol="0" anchor="ctr" tIns="73152"/>
+          <a:bodyPr rtlCol="0" anchor="ctr" tIns="54864"/>
           <a:lstStyle/>
           <a:p>
             <a:pPr algn="ctr">
-              <a:defRPr sz="1200" b="1">
-                <a:solidFill>
-                  <a:srgbClr val="10B981"/>
-                </a:solidFill>
-                <a:latin typeface="Segoe UI"/>
-              </a:defRPr>
-            </a:pPr>
-            <a:r>
-              <a:t>UNIVERSIDADE ESTADUAL DO MARANHÃO — UEMA</a:t>
-            </a:r>
-          </a:p>
-        </p:txBody>
-      </p:sp>
-      <p:sp>
-        <p:nvSpPr>
-          <p:cNvPr id="4" name="TextBox 3"/>
-          <p:cNvSpPr txBox="1"/>
-          <p:nvPr/>
-        </p:nvSpPr>
-        <p:spPr>
-          <a:xfrm>
-            <a:off x="1371600" y="1234440"/>
-            <a:ext cx="9448495" cy="457200"/>
-          </a:xfrm>
-          <a:prstGeom prst="rect">
-            <a:avLst/>
-          </a:prstGeom>
-          <a:noFill/>
-        </p:spPr>
-        <p:txBody>
-          <a:bodyPr wrap="none">
-            <a:spAutoFit/>
-          </a:bodyPr>
-          <a:lstStyle/>
-          <a:p>
-            <a:pPr algn="ctr">
-              <a:defRPr sz="1300">
-                <a:solidFill>
-                  <a:srgbClr val="CBD5E1"/>
-                </a:solidFill>
-                <a:latin typeface="Segoe UI"/>
-              </a:defRPr>
-            </a:pPr>
-            <a:r>
-              <a:t>CST em Análise e Desenvolvimento de Sistemas  |  Desenvolvimento Web  |  Nota 2</a:t>
-            </a:r>
-          </a:p>
-        </p:txBody>
-      </p:sp>
-      <p:sp>
-        <p:nvSpPr>
-          <p:cNvPr id="5" name="TextBox 4"/>
-          <p:cNvSpPr txBox="1"/>
-          <p:nvPr/>
-        </p:nvSpPr>
-        <p:spPr>
-          <a:xfrm>
-            <a:off x="1371600" y="1874519"/>
-            <a:ext cx="9448495" cy="1188720"/>
-          </a:xfrm>
-          <a:prstGeom prst="rect">
-            <a:avLst/>
-          </a:prstGeom>
-          <a:noFill/>
-        </p:spPr>
-        <p:txBody>
-          <a:bodyPr wrap="none">
-            <a:spAutoFit/>
-          </a:bodyPr>
-          <a:lstStyle/>
-          <a:p>
-            <a:pPr algn="ctr">
-              <a:defRPr sz="4600" b="1">
+              <a:defRPr sz="1100" b="1">
                 <a:solidFill>
                   <a:srgbClr val="4ADE80"/>
                 </a:solidFill>
@@ -3265,7 +3337,7 @@
               </a:defRPr>
             </a:pPr>
             <a:r>
-              <a:t>Timbiras Solidária 🏹</a:t>
+              <a:t>TECNOLOGIA A SERVIÇO DA VIDA  •  ODS 2 &amp; ODS 11</a:t>
             </a:r>
           </a:p>
         </p:txBody>
@@ -3278,8 +3350,8 @@
         </p:nvSpPr>
         <p:spPr>
           <a:xfrm>
-            <a:off x="1645920" y="3154680"/>
-            <a:ext cx="8899855" cy="1005840"/>
+            <a:off x="1371600" y="2423160"/>
+            <a:ext cx="9448495" cy="1097280"/>
           </a:xfrm>
           <a:prstGeom prst="rect">
             <a:avLst/>
@@ -3292,8 +3364,61 @@
           </a:bodyPr>
           <a:lstStyle/>
           <a:p>
+            <a:pPr algn="ctr"/>
+            <a:r>
+              <a:rPr sz="4600" b="1">
+                <a:solidFill>
+                  <a:srgbClr val="FFFFFF"/>
+                </a:solidFill>
+                <a:latin typeface="Segoe UI"/>
+              </a:rPr>
+              <a:t>TIMBIRAS </a:t>
+            </a:r>
+            <a:r>
+              <a:rPr sz="4600" b="1">
+                <a:solidFill>
+                  <a:srgbClr val="4ADE80"/>
+                </a:solidFill>
+                <a:latin typeface="Segoe UI"/>
+              </a:rPr>
+              <a:t>SOLIDÁRIA </a:t>
+            </a:r>
+            <a:r>
+              <a:rPr sz="4000">
+                <a:solidFill>
+                  <a:srgbClr val="FFFFFF"/>
+                </a:solidFill>
+                <a:latin typeface="Segoe UI"/>
+              </a:rPr>
+              <a:t>🏹</a:t>
+            </a:r>
+          </a:p>
+        </p:txBody>
+      </p:sp>
+      <p:sp>
+        <p:nvSpPr>
+          <p:cNvPr id="7" name="TextBox 6"/>
+          <p:cNvSpPr txBox="1"/>
+          <p:nvPr/>
+        </p:nvSpPr>
+        <p:spPr>
+          <a:xfrm>
+            <a:off x="1645920" y="3566160"/>
+            <a:ext cx="8899855" cy="1005840"/>
+          </a:xfrm>
+          <a:prstGeom prst="rect">
+            <a:avLst/>
+          </a:prstGeom>
+          <a:noFill/>
+        </p:spPr>
+        <p:txBody>
+          <a:bodyPr wrap="square">
+            <a:spAutoFit/>
+          </a:bodyPr>
+          <a:lstStyle/>
+          <a:p>
             <a:pPr algn="ctr">
-              <a:defRPr sz="1700">
+              <a:defRPr sz="1600">
                 <a:solidFill>
                   <a:srgbClr val="F1F5F9"/>
                 </a:solidFill>
@@ -3301,21 +3426,34 @@
               </a:defRPr>
             </a:pPr>
             <a:r>
-              <a:t>Como a tecnologia web pode encurtar distâncias, combater a fome e unir uma comunidade inteira em torno do ODS 2 da ONU.</a:t>
-            </a:r>
-          </a:p>
-        </p:txBody>
-      </p:sp>
-      <p:sp>
-        <p:nvSpPr>
-          <p:cNvPr id="7" name="Rounded Rectangle 6"/>
+              <a:t>Plataforma Web Comunitária de Mapeamento, Solidariedade e Resiliência Alimentar no Interior do Maranhão</a:t>
+            </a:r>
+          </a:p>
+          <a:p>
+            <a:pPr algn="ctr">
+              <a:defRPr sz="1250">
+                <a:solidFill>
+                  <a:srgbClr val="CBD5E1"/>
+                </a:solidFill>
+                <a:latin typeface="Segoe UI"/>
+              </a:defRPr>
+            </a:pPr>
+            <a:r>
+              <a:t>Uma ponte digital entre a generosidade de quem pode doar e a dignidade de quem precisa receber</a:t>
+            </a:r>
+          </a:p>
+        </p:txBody>
+      </p:sp>
+      <p:sp>
+        <p:nvSpPr>
+          <p:cNvPr id="8" name="Rounded Rectangle 7"/>
           <p:cNvSpPr/>
           <p:nvPr/>
         </p:nvSpPr>
         <p:spPr>
           <a:xfrm>
-            <a:off x="1645920" y="4434840"/>
-            <a:ext cx="8899855" cy="1600200"/>
+            <a:off x="1645920" y="4754880"/>
+            <a:ext cx="8899855" cy="1508760"/>
           </a:xfrm>
           <a:prstGeom prst="roundRect">
             <a:avLst/>
@@ -3344,11 +3482,11 @@
           </a:fontRef>
         </p:style>
         <p:txBody>
-          <a:bodyPr rtlCol="0" anchor="ctr" tIns="182880"/>
+          <a:bodyPr rtlCol="0" anchor="ctr" tIns="164592"/>
           <a:lstStyle/>
           <a:p>
             <a:pPr algn="ctr">
-              <a:defRPr sz="1300" b="1">
+              <a:defRPr sz="1250" b="1">
                 <a:solidFill>
                   <a:srgbClr val="4ADE80"/>
                 </a:solidFill>
@@ -3374,7 +3512,7 @@
           </a:p>
           <a:p>
             <a:pPr algn="ctr">
-              <a:defRPr sz="1200">
+              <a:defRPr sz="1150">
                 <a:solidFill>
                   <a:srgbClr val="94A3B8"/>
                 </a:solidFill>
@@ -3721,7 +3859,7 @@
           </a:bodyPr>
           <a:lstStyle/>
           <a:p>
-            <a:pPr>
+            <a:pPr algn="just">
               <a:defRPr sz="1200" b="1">
                 <a:solidFill>
                   <a:srgbClr val="00873E"/>
@@ -3752,7 +3890,7 @@
         <p:spPr>
           <a:xfrm>
             <a:off x="868680" y="1737360"/>
-            <a:ext cx="4892040" cy="2653735"/>
+            <a:ext cx="4892040" cy="2750430"/>
           </a:xfrm>
           <a:prstGeom prst="rect">
             <a:avLst/>
@@ -3781,7 +3919,7 @@
           </a:bodyPr>
           <a:lstStyle/>
           <a:p>
-            <a:pPr>
+            <a:pPr algn="just">
               <a:defRPr sz="1000">
                 <a:solidFill>
                   <a:srgbClr val="64748B"/>
@@ -3893,7 +4031,7 @@
         <p:spPr>
           <a:xfrm>
             <a:off x="6400800" y="1737360"/>
-            <a:ext cx="4892040" cy="3874954"/>
+            <a:ext cx="4892040" cy="2750430"/>
           </a:xfrm>
           <a:prstGeom prst="rect">
             <a:avLst/>
@@ -3922,7 +4060,7 @@
           </a:bodyPr>
           <a:lstStyle/>
           <a:p>
-            <a:pPr>
+            <a:pPr algn="just">
               <a:defRPr sz="1000">
                 <a:solidFill>
                   <a:srgbClr val="64748B"/>
@@ -4301,7 +4439,7 @@
         <p:spPr>
           <a:xfrm>
             <a:off x="868680" y="1737360"/>
-            <a:ext cx="4892040" cy="3334180"/>
+            <a:ext cx="4892040" cy="2750430"/>
           </a:xfrm>
           <a:prstGeom prst="rect">
             <a:avLst/>
@@ -4330,7 +4468,7 @@
           </a:bodyPr>
           <a:lstStyle/>
           <a:p>
-            <a:pPr>
+            <a:pPr algn="just">
               <a:defRPr sz="1000">
                 <a:solidFill>
                   <a:srgbClr val="64748B"/>
@@ -4442,7 +4580,7 @@
         <p:spPr>
           <a:xfrm>
             <a:off x="6400800" y="1737360"/>
-            <a:ext cx="4892040" cy="3688727"/>
+            <a:ext cx="4892040" cy="2750430"/>
           </a:xfrm>
           <a:prstGeom prst="rect">
             <a:avLst/>
@@ -4471,7 +4609,7 @@
           </a:bodyPr>
           <a:lstStyle/>
           <a:p>
-            <a:pPr>
+            <a:pPr algn="just">
               <a:defRPr sz="1000">
                 <a:solidFill>
                   <a:srgbClr val="64748B"/>
@@ -4915,7 +5053,7 @@
           </a:bodyPr>
           <a:lstStyle/>
           <a:p>
-            <a:pPr>
+            <a:pPr algn="just">
               <a:defRPr sz="1600" b="1">
                 <a:solidFill>
                   <a:srgbClr val="00873E"/>
@@ -4928,7 +5066,7 @@
             </a:r>
           </a:p>
           <a:p>
-            <a:pPr>
+            <a:pPr algn="just">
               <a:defRPr sz="1150">
                 <a:solidFill>
                   <a:srgbClr val="64748B"/>
@@ -5065,7 +5203,7 @@
             </a:r>
           </a:p>
           <a:p>
-            <a:pPr>
+            <a:pPr algn="just">
               <a:defRPr sz="1050">
                 <a:solidFill>
                   <a:srgbClr val="64748B"/>
@@ -5202,7 +5340,7 @@
             </a:r>
           </a:p>
           <a:p>
-            <a:pPr>
+            <a:pPr algn="just">
               <a:defRPr sz="1050">
                 <a:solidFill>
                   <a:srgbClr val="64748B"/>
@@ -5339,7 +5477,7 @@
             </a:r>
           </a:p>
           <a:p>
-            <a:pPr>
+            <a:pPr algn="just">
               <a:defRPr sz="1050">
                 <a:solidFill>
                   <a:srgbClr val="64748B"/>
@@ -5476,7 +5614,7 @@
             </a:r>
           </a:p>
           <a:p>
-            <a:pPr>
+            <a:pPr algn="just">
               <a:defRPr sz="1050">
                 <a:solidFill>
                   <a:srgbClr val="64748B"/>
@@ -5881,7 +6019,7 @@
           </a:p>
           <a:p>
             <a:br/>
-            <a:pPr>
+            <a:pPr algn="just">
               <a:defRPr sz="1150">
                 <a:solidFill>
                   <a:srgbClr val="1E293B"/>
@@ -6019,7 +6157,7 @@
           </a:p>
           <a:p>
             <a:br/>
-            <a:pPr>
+            <a:pPr algn="just">
               <a:defRPr sz="1150">
                 <a:solidFill>
                   <a:srgbClr val="1E293B"/>
@@ -6114,7 +6252,7 @@
           </a:p>
           <a:p>
             <a:br/>
-            <a:pPr>
+            <a:pPr algn="just">
               <a:defRPr sz="900">
                 <a:solidFill>
                   <a:srgbClr val="64748B"/>
@@ -6128,7 +6266,7 @@
           </a:p>
           <a:p>
             <a:br/>
-            <a:pPr>
+            <a:pPr algn="just">
               <a:defRPr sz="900">
                 <a:solidFill>
                   <a:srgbClr val="64748B"/>
@@ -6142,7 +6280,7 @@
           </a:p>
           <a:p>
             <a:br/>
-            <a:pPr>
+            <a:pPr algn="just">
               <a:defRPr sz="900">
                 <a:solidFill>
                   <a:srgbClr val="64748B"/>
@@ -6156,7 +6294,7 @@
           </a:p>
           <a:p>
             <a:br/>
-            <a:pPr>
+            <a:pPr algn="just">
               <a:defRPr sz="900">
                 <a:solidFill>
                   <a:srgbClr val="64748B"/>
@@ -6170,7 +6308,7 @@
           </a:p>
           <a:p>
             <a:br/>
-            <a:pPr>
+            <a:pPr algn="just">
               <a:defRPr sz="900">
                 <a:solidFill>
                   <a:srgbClr val="64748B"/>
@@ -6184,7 +6322,7 @@
           </a:p>
           <a:p>
             <a:br/>
-            <a:pPr>
+            <a:pPr algn="just">
               <a:defRPr sz="900">
                 <a:solidFill>
                   <a:srgbClr val="64748B"/>
@@ -6487,7 +6625,7 @@
           </a:bodyPr>
           <a:lstStyle/>
           <a:p>
-            <a:pPr>
+            <a:pPr algn="just">
               <a:defRPr sz="1550" b="1">
                 <a:solidFill>
                   <a:srgbClr val="1E293B"/>
@@ -6501,7 +6639,7 @@
           </a:p>
           <a:p>
             <a:br/>
-            <a:pPr>
+            <a:pPr algn="just">
               <a:defRPr sz="1250">
                 <a:solidFill>
                   <a:srgbClr val="64748B"/>
@@ -6639,7 +6777,7 @@
           </a:p>
           <a:p>
             <a:br/>
-            <a:pPr>
+            <a:pPr algn="just">
               <a:defRPr sz="1150">
                 <a:solidFill>
                   <a:srgbClr val="1E293B"/>
@@ -6733,7 +6871,7 @@
             </a:r>
           </a:p>
           <a:p>
-            <a:pPr>
+            <a:pPr algn="just">
               <a:defRPr sz="1150">
                 <a:solidFill>
                   <a:srgbClr val="1E293B"/>
@@ -6760,7 +6898,7 @@
             </a:r>
           </a:p>
           <a:p>
-            <a:pPr>
+            <a:pPr algn="just">
               <a:defRPr sz="1100">
                 <a:solidFill>
                   <a:srgbClr val="1E293B"/>
@@ -6773,7 +6911,7 @@
             </a:r>
           </a:p>
           <a:p>
-            <a:pPr>
+            <a:pPr algn="just">
               <a:defRPr sz="1100">
                 <a:solidFill>
                   <a:srgbClr val="1E293B"/>
@@ -6786,7 +6924,7 @@
             </a:r>
           </a:p>
           <a:p>
-            <a:pPr>
+            <a:pPr algn="just">
               <a:defRPr sz="1100">
                 <a:solidFill>
                   <a:srgbClr val="1E293B"/>
@@ -6799,7 +6937,7 @@
             </a:r>
           </a:p>
           <a:p>
-            <a:pPr>
+            <a:pPr algn="just">
               <a:defRPr sz="1100">
                 <a:solidFill>
                   <a:srgbClr val="1E293B"/>
@@ -7116,7 +7254,7 @@
           </a:p>
           <a:p>
             <a:br/>
-            <a:pPr>
+            <a:pPr algn="just">
               <a:defRPr sz="1200">
                 <a:solidFill>
                   <a:srgbClr val="64748B"/>
@@ -7130,7 +7268,7 @@
           </a:p>
           <a:p>
             <a:br/>
-            <a:pPr>
+            <a:pPr algn="just">
               <a:defRPr sz="1200">
                 <a:solidFill>
                   <a:srgbClr val="64748B"/>
@@ -7268,7 +7406,7 @@
           </a:p>
           <a:p>
             <a:br/>
-            <a:pPr>
+            <a:pPr algn="just">
               <a:defRPr sz="1150">
                 <a:solidFill>
                   <a:srgbClr val="1E293B"/>
@@ -7363,7 +7501,7 @@
           </a:p>
           <a:p>
             <a:br/>
-            <a:pPr>
+            <a:pPr algn="just">
               <a:defRPr sz="1150">
                 <a:solidFill>
                   <a:srgbClr val="1E293B"/>
@@ -7377,7 +7515,7 @@
           </a:p>
           <a:p>
             <a:br/>
-            <a:pPr>
+            <a:pPr algn="just">
               <a:defRPr sz="1150">
                 <a:solidFill>
                   <a:srgbClr val="1E293B"/>
@@ -7391,7 +7529,7 @@
           </a:p>
           <a:p>
             <a:br/>
-            <a:pPr>
+            <a:pPr algn="just">
               <a:defRPr sz="1150">
                 <a:solidFill>
                   <a:srgbClr val="1E293B"/>
@@ -7405,7 +7543,7 @@
           </a:p>
           <a:p>
             <a:br/>
-            <a:pPr>
+            <a:pPr algn="just">
               <a:defRPr sz="1150">
                 <a:solidFill>
                   <a:srgbClr val="1E293B"/>
@@ -7708,7 +7846,7 @@
           </a:bodyPr>
           <a:lstStyle/>
           <a:p>
-            <a:pPr>
+            <a:pPr algn="just">
               <a:defRPr sz="1550" b="1">
                 <a:solidFill>
                   <a:srgbClr val="00873E"/>
@@ -7721,7 +7859,7 @@
             </a:r>
           </a:p>
           <a:p>
-            <a:pPr>
+            <a:pPr algn="just">
               <a:defRPr sz="1200">
                 <a:solidFill>
                   <a:srgbClr val="64748B"/>
@@ -7858,7 +7996,7 @@
             </a:r>
           </a:p>
           <a:p>
-            <a:pPr>
+            <a:pPr algn="just">
               <a:defRPr sz="1050">
                 <a:solidFill>
                   <a:srgbClr val="1E293B"/>
@@ -7871,7 +8009,7 @@
             </a:r>
           </a:p>
           <a:p>
-            <a:pPr>
+            <a:pPr algn="just">
               <a:defRPr sz="1050">
                 <a:solidFill>
                   <a:srgbClr val="1E293B"/>
@@ -7884,7 +8022,7 @@
             </a:r>
           </a:p>
           <a:p>
-            <a:pPr>
+            <a:pPr algn="just">
               <a:defRPr sz="1050">
                 <a:solidFill>
                   <a:srgbClr val="1E293B"/>
@@ -7897,7 +8035,7 @@
             </a:r>
           </a:p>
           <a:p>
-            <a:pPr>
+            <a:pPr algn="just">
               <a:defRPr sz="1050">
                 <a:solidFill>
                   <a:srgbClr val="1E293B"/>
@@ -7933,7 +8071,7 @@
           </a:bodyPr>
           <a:lstStyle/>
           <a:p>
-            <a:pPr>
+            <a:pPr algn="just">
               <a:defRPr sz="1500" b="1">
                 <a:solidFill>
                   <a:srgbClr val="00873E"/>
@@ -7946,7 +8084,7 @@
             </a:r>
           </a:p>
           <a:p>
-            <a:pPr>
+            <a:pPr algn="just">
               <a:defRPr sz="1150">
                 <a:solidFill>
                   <a:srgbClr val="64748B"/>
@@ -8041,7 +8179,7 @@
           </a:p>
           <a:p>
             <a:br/>
-            <a:pPr>
+            <a:pPr algn="just">
               <a:defRPr sz="1100">
                 <a:solidFill>
                   <a:srgbClr val="1E293B"/>
@@ -8055,7 +8193,7 @@
           </a:p>
           <a:p>
             <a:br/>
-            <a:pPr>
+            <a:pPr algn="just">
               <a:defRPr sz="1100">
                 <a:solidFill>
                   <a:srgbClr val="1E293B"/>
@@ -8372,7 +8510,7 @@
           </a:p>
           <a:p>
             <a:br/>
-            <a:pPr>
+            <a:pPr algn="just">
               <a:defRPr sz="1200">
                 <a:solidFill>
                   <a:srgbClr val="64748B"/>
@@ -8453,7 +8591,7 @@
           </a:bodyPr>
           <a:lstStyle/>
           <a:p>
-            <a:pPr>
+            <a:pPr algn="l">
               <a:defRPr sz="1050" b="1">
                 <a:solidFill>
                   <a:srgbClr val="38BDF8"/>
@@ -8489,7 +8627,7 @@
           </a:bodyPr>
           <a:lstStyle/>
           <a:p>
-            <a:pPr>
+            <a:pPr algn="just">
               <a:defRPr sz="1150">
                 <a:solidFill>
                   <a:srgbClr val="1E293B"/>
@@ -8584,7 +8722,7 @@
           </a:p>
           <a:p>
             <a:br/>
-            <a:pPr>
+            <a:pPr algn="just">
               <a:defRPr sz="1100">
                 <a:solidFill>
                   <a:srgbClr val="1E293B"/>
@@ -8602,7 +8740,7 @@
           </a:p>
           <a:p>
             <a:br/>
-            <a:pPr>
+            <a:pPr algn="just">
               <a:defRPr sz="1100">
                 <a:solidFill>
                   <a:srgbClr val="1E293B"/>
@@ -8620,7 +8758,7 @@
           </a:p>
           <a:p>
             <a:br/>
-            <a:pPr>
+            <a:pPr algn="just">
               <a:defRPr sz="1100">
                 <a:solidFill>
                   <a:srgbClr val="1E293B"/>
@@ -8986,7 +9124,7 @@
           </a:p>
           <a:p>
             <a:br/>
-            <a:pPr>
+            <a:pPr algn="l">
               <a:defRPr sz="1050">
                 <a:solidFill>
                   <a:srgbClr val="E2E8F0"/>
@@ -9190,7 +9328,7 @@
           </a:p>
           <a:p>
             <a:br/>
-            <a:pPr>
+            <a:pPr algn="just">
               <a:defRPr sz="1150">
                 <a:solidFill>
                   <a:srgbClr val="1E293B"/>
@@ -9328,7 +9466,7 @@
           </a:p>
           <a:p>
             <a:br/>
-            <a:pPr>
+            <a:pPr algn="just">
               <a:defRPr sz="1150">
                 <a:solidFill>
                   <a:srgbClr val="1E293B"/>
@@ -9690,7 +9828,7 @@
           </a:p>
           <a:p>
             <a:br/>
-            <a:pPr>
+            <a:pPr algn="l">
               <a:defRPr sz="1000">
                 <a:solidFill>
                   <a:srgbClr val="1E293B"/>
@@ -9872,7 +10010,7 @@
           </a:p>
           <a:p>
             <a:br/>
-            <a:pPr>
+            <a:pPr algn="just">
               <a:defRPr sz="1150">
                 <a:solidFill>
                   <a:srgbClr val="1E293B"/>
@@ -9966,7 +10104,7 @@
             </a:r>
           </a:p>
           <a:p>
-            <a:pPr>
+            <a:pPr algn="just">
               <a:defRPr sz="1100">
                 <a:solidFill>
                   <a:srgbClr val="1E293B"/>
@@ -9979,7 +10117,7 @@
             </a:r>
           </a:p>
           <a:p>
-            <a:pPr>
+            <a:pPr algn="just">
               <a:defRPr sz="1100">
                 <a:solidFill>
                   <a:srgbClr val="1E293B"/>
@@ -9992,7 +10130,7 @@
             </a:r>
           </a:p>
           <a:p>
-            <a:pPr>
+            <a:pPr algn="just">
               <a:defRPr sz="1100">
                 <a:solidFill>
                   <a:srgbClr val="1E293B"/>
@@ -10005,7 +10143,7 @@
             </a:r>
           </a:p>
           <a:p>
-            <a:pPr>
+            <a:pPr algn="just">
               <a:defRPr sz="1100">
                 <a:solidFill>
                   <a:srgbClr val="1E293B"/>
@@ -10445,7 +10583,7 @@
             </a:r>
           </a:p>
           <a:p>
-            <a:pPr>
+            <a:pPr algn="just">
               <a:defRPr sz="1050">
                 <a:solidFill>
                   <a:srgbClr val="64748B"/>
@@ -10582,7 +10720,7 @@
             </a:r>
           </a:p>
           <a:p>
-            <a:pPr>
+            <a:pPr algn="just">
               <a:defRPr sz="1050">
                 <a:solidFill>
                   <a:srgbClr val="64748B"/>
@@ -10719,7 +10857,7 @@
             </a:r>
           </a:p>
           <a:p>
-            <a:pPr>
+            <a:pPr algn="just">
               <a:defRPr sz="1050">
                 <a:solidFill>
                   <a:srgbClr val="64748B"/>
@@ -10814,7 +10952,7 @@
           </a:p>
           <a:p>
             <a:br/>
-            <a:pPr>
+            <a:pPr algn="just">
               <a:defRPr sz="1150">
                 <a:solidFill>
                   <a:srgbClr val="1E293B"/>
@@ -10828,7 +10966,7 @@
           </a:p>
           <a:p>
             <a:br/>
-            <a:pPr>
+            <a:pPr algn="just">
               <a:defRPr sz="1150">
                 <a:solidFill>
                   <a:srgbClr val="1E293B"/>
@@ -10842,7 +10980,7 @@
           </a:p>
           <a:p>
             <a:br/>
-            <a:pPr>
+            <a:pPr algn="just">
               <a:defRPr sz="1150">
                 <a:solidFill>
                   <a:srgbClr val="1E293B"/>
@@ -10856,7 +10994,7 @@
           </a:p>
           <a:p>
             <a:br/>
-            <a:pPr>
+            <a:pPr algn="just">
               <a:defRPr sz="1150">
                 <a:solidFill>
                   <a:srgbClr val="1E293B"/>
@@ -11268,7 +11406,7 @@
           </a:p>
           <a:p>
             <a:br/>
-            <a:pPr algn="ctr">
+            <a:pPr algn="l">
               <a:defRPr sz="1050" b="1">
                 <a:solidFill>
                   <a:srgbClr val="00873E"/>
@@ -11377,7 +11515,7 @@
           </a:p>
           <a:p>
             <a:br/>
-            <a:pPr algn="ctr">
+            <a:pPr algn="l">
               <a:defRPr sz="1050" b="1">
                 <a:solidFill>
                   <a:srgbClr val="0284C7"/>

</xml_diff>